<commit_message>
Edit to Presentation:  removed some errors
</commit_message>
<xml_diff>
--- a/T9998_VIT-Chennai_Rahi_Sanxipt_Mehta.pptx
+++ b/T9998_VIT-Chennai_Rahi_Sanxipt_Mehta.pptx
@@ -6908,50 +6908,6 @@
           </a:p>
         </p:txBody>
       </p:sp>
-      <p:sp>
-        <p:nvSpPr>
-          <p:cNvPr id="4" name="TextBox 4"/>
-          <p:cNvSpPr txBox="1"/>
-          <p:nvPr/>
-        </p:nvSpPr>
-        <p:spPr>
-          <a:xfrm>
-            <a:off x="2988220" y="5322138"/>
-            <a:ext cx="12311559" cy="629303"/>
-          </a:xfrm>
-          <a:prstGeom prst="rect">
-            <a:avLst/>
-          </a:prstGeom>
-        </p:spPr>
-        <p:txBody>
-          <a:bodyPr lIns="0" tIns="0" rIns="0" bIns="0" rtlCol="0" anchor="t">
-            <a:spAutoFit/>
-          </a:bodyPr>
-          <a:lstStyle/>
-          <a:p>
-            <a:pPr algn="ctr">
-              <a:lnSpc>
-                <a:spcPts val="5213"/>
-              </a:lnSpc>
-              <a:spcBef>
-                <a:spcPct val="0"/>
-              </a:spcBef>
-            </a:pPr>
-            <a:r>
-              <a:rPr lang="en-US" sz="3724" b="1">
-                <a:solidFill>
-                  <a:srgbClr val="000000"/>
-                </a:solidFill>
-                <a:latin typeface="Montserrat Bold"/>
-                <a:ea typeface="Montserrat Bold"/>
-                <a:cs typeface="Montserrat Bold"/>
-                <a:sym typeface="Montserrat Bold"/>
-              </a:rPr>
-              <a:t>www.reallygreatsite.com</a:t>
-            </a:r>
-          </a:p>
-        </p:txBody>
-      </p:sp>
     </p:spTree>
   </p:cSld>
   <p:clrMapOvr>

</xml_diff>